<commit_message>
cleaning up 304 repo
</commit_message>
<xml_diff>
--- a/ClassMaterials/CPSDatatypesInterpreter/CPSInInterperter.pptx
+++ b/ClassMaterials/CPSDatatypesInterpreter/CPSInInterperter.pptx
@@ -4639,6 +4639,14 @@
 <file path=ppt/slides/slide1.xml><?xml version="1.0" encoding="utf-8"?>
 <p:sld xmlns:a="http://schemas.openxmlformats.org/drawingml/2006/main" xmlns:r="http://schemas.openxmlformats.org/officeDocument/2006/relationships" xmlns:p="http://schemas.openxmlformats.org/presentationml/2006/main">
   <p:cSld>
+    <p:bg>
+      <p:bgPr>
+        <a:solidFill>
+          <a:schemeClr val="bg1"/>
+        </a:solidFill>
+        <a:effectLst/>
+      </p:bgPr>
+    </p:bg>
     <p:spTree>
       <p:nvGrpSpPr>
         <p:cNvPr id="1" name=""/>
@@ -4653,6 +4661,479 @@
           <a:chExt cx="0" cy="0"/>
         </a:xfrm>
       </p:grpSpPr>
+      <p:sp useBgFill="1">
+        <p:nvSpPr>
+          <p:cNvPr id="10" name="Rectangle 9">
+            <a:extLst>
+              <a:ext uri="{FF2B5EF4-FFF2-40B4-BE49-F238E27FC236}">
+                <a16:creationId xmlns:a16="http://schemas.microsoft.com/office/drawing/2014/main" id="{A8384FB5-9ADC-4DDC-881B-597D56F5B15D}"/>
+              </a:ext>
+              <a:ext uri="{C183D7F6-B498-43B3-948B-1728B52AA6E4}">
+                <adec:decorative xmlns:adec="http://schemas.microsoft.com/office/drawing/2017/decorative" val="1"/>
+              </a:ext>
+            </a:extLst>
+          </p:cNvPr>
+          <p:cNvSpPr>
+            <a:spLocks noGrp="1" noRot="1" noChangeAspect="1" noMove="1" noResize="1" noEditPoints="1" noAdjustHandles="1" noChangeArrowheads="1" noChangeShapeType="1" noTextEdit="1"/>
+          </p:cNvSpPr>
+          <p:nvPr>
+            <p:extLst>
+              <p:ext uri="{386F3935-93C4-4BCD-93E2-E3B085C9AB24}">
+                <p16:designElem xmlns:p16="http://schemas.microsoft.com/office/powerpoint/2015/main" val="1"/>
+              </p:ext>
+            </p:extLst>
+          </p:nvPr>
+        </p:nvSpPr>
+        <p:spPr>
+          <a:xfrm>
+            <a:off x="0" y="0"/>
+            <a:ext cx="9144000" cy="6858000"/>
+          </a:xfrm>
+          <a:prstGeom prst="rect">
+            <a:avLst/>
+          </a:prstGeom>
+          <a:ln w="12700" cap="flat" cmpd="sng" algn="ctr">
+            <a:noFill/>
+            <a:prstDash val="solid"/>
+            <a:miter lim="800000"/>
+          </a:ln>
+          <a:effectLst/>
+          <a:extLst>
+            <a:ext uri="{91240B29-F687-4F45-9708-019B960494DF}">
+              <a14:hiddenLine xmlns:a14="http://schemas.microsoft.com/office/drawing/2010/main" w="12700" cap="flat" cmpd="sng" algn="ctr">
+                <a:solidFill>
+                  <a:schemeClr val="accent1">
+                    <a:shade val="50000"/>
+                  </a:schemeClr>
+                </a:solidFill>
+                <a:prstDash val="solid"/>
+                <a:miter lim="800000"/>
+              </a14:hiddenLine>
+            </a:ext>
+          </a:extLst>
+        </p:spPr>
+        <p:style>
+          <a:lnRef idx="2">
+            <a:schemeClr val="accent1">
+              <a:shade val="50000"/>
+            </a:schemeClr>
+          </a:lnRef>
+          <a:fillRef idx="1">
+            <a:schemeClr val="accent1"/>
+          </a:fillRef>
+          <a:effectRef idx="0">
+            <a:schemeClr val="accent1"/>
+          </a:effectRef>
+          <a:fontRef idx="minor">
+            <a:schemeClr val="lt1"/>
+          </a:fontRef>
+        </p:style>
+        <p:txBody>
+          <a:bodyPr rtlCol="0" anchor="ctr"/>
+          <a:lstStyle/>
+          <a:p>
+            <a:pPr algn="ctr"/>
+            <a:endParaRPr lang="en-US"/>
+          </a:p>
+        </p:txBody>
+      </p:sp>
+      <p:sp>
+        <p:nvSpPr>
+          <p:cNvPr id="12" name="Rectangle 11">
+            <a:extLst>
+              <a:ext uri="{FF2B5EF4-FFF2-40B4-BE49-F238E27FC236}">
+                <a16:creationId xmlns:a16="http://schemas.microsoft.com/office/drawing/2014/main" id="{91E5A9A7-95C6-4F4F-B00E-C82E07FE62EF}"/>
+              </a:ext>
+              <a:ext uri="{C183D7F6-B498-43B3-948B-1728B52AA6E4}">
+                <adec:decorative xmlns:adec="http://schemas.microsoft.com/office/drawing/2017/decorative" val="1"/>
+              </a:ext>
+            </a:extLst>
+          </p:cNvPr>
+          <p:cNvSpPr>
+            <a:spLocks noGrp="1" noRot="1" noChangeAspect="1" noMove="1" noResize="1" noEditPoints="1" noAdjustHandles="1" noChangeArrowheads="1" noChangeShapeType="1" noTextEdit="1"/>
+          </p:cNvSpPr>
+          <p:nvPr>
+            <p:extLst>
+              <p:ext uri="{386F3935-93C4-4BCD-93E2-E3B085C9AB24}">
+                <p16:designElem xmlns:p16="http://schemas.microsoft.com/office/powerpoint/2015/main" val="1"/>
+              </p:ext>
+            </p:extLst>
+          </p:nvPr>
+        </p:nvSpPr>
+        <p:spPr>
+          <a:xfrm rot="5400000" flipH="1">
+            <a:off x="-1922632" y="1922631"/>
+            <a:ext cx="6875818" cy="3030558"/>
+          </a:xfrm>
+          <a:prstGeom prst="rect">
+            <a:avLst/>
+          </a:prstGeom>
+          <a:gradFill>
+            <a:gsLst>
+              <a:gs pos="0">
+                <a:srgbClr val="000000"/>
+              </a:gs>
+              <a:gs pos="100000">
+                <a:schemeClr val="accent1">
+                  <a:lumMod val="75000"/>
+                </a:schemeClr>
+              </a:gs>
+            </a:gsLst>
+            <a:lin ang="18600000" scaled="0"/>
+          </a:gradFill>
+          <a:ln>
+            <a:noFill/>
+          </a:ln>
+        </p:spPr>
+        <p:style>
+          <a:lnRef idx="2">
+            <a:schemeClr val="accent1">
+              <a:shade val="50000"/>
+            </a:schemeClr>
+          </a:lnRef>
+          <a:fillRef idx="1">
+            <a:schemeClr val="accent1"/>
+          </a:fillRef>
+          <a:effectRef idx="0">
+            <a:schemeClr val="accent1"/>
+          </a:effectRef>
+          <a:fontRef idx="minor">
+            <a:schemeClr val="lt1"/>
+          </a:fontRef>
+        </p:style>
+        <p:txBody>
+          <a:bodyPr rtlCol="0" anchor="ctr"/>
+          <a:lstStyle/>
+          <a:p>
+            <a:pPr algn="ctr"/>
+            <a:endParaRPr lang="en-US" dirty="0"/>
+          </a:p>
+        </p:txBody>
+      </p:sp>
+      <p:sp>
+        <p:nvSpPr>
+          <p:cNvPr id="14" name="Rectangle 13">
+            <a:extLst>
+              <a:ext uri="{FF2B5EF4-FFF2-40B4-BE49-F238E27FC236}">
+                <a16:creationId xmlns:a16="http://schemas.microsoft.com/office/drawing/2014/main" id="{D07DD2DE-F619-49DD-B5E7-03A290FF4ED1}"/>
+              </a:ext>
+              <a:ext uri="{C183D7F6-B498-43B3-948B-1728B52AA6E4}">
+                <adec:decorative xmlns:adec="http://schemas.microsoft.com/office/drawing/2017/decorative" val="1"/>
+              </a:ext>
+            </a:extLst>
+          </p:cNvPr>
+          <p:cNvSpPr>
+            <a:spLocks noGrp="1" noRot="1" noChangeAspect="1" noMove="1" noResize="1" noEditPoints="1" noAdjustHandles="1" noChangeArrowheads="1" noChangeShapeType="1" noTextEdit="1"/>
+          </p:cNvSpPr>
+          <p:nvPr>
+            <p:extLst>
+              <p:ext uri="{386F3935-93C4-4BCD-93E2-E3B085C9AB24}">
+                <p16:designElem xmlns:p16="http://schemas.microsoft.com/office/powerpoint/2015/main" val="1"/>
+              </p:ext>
+            </p:extLst>
+          </p:nvPr>
+        </p:nvSpPr>
+        <p:spPr>
+          <a:xfrm rot="16200000">
+            <a:off x="-663321" y="3165298"/>
+            <a:ext cx="4355594" cy="3028952"/>
+          </a:xfrm>
+          <a:prstGeom prst="rect">
+            <a:avLst/>
+          </a:prstGeom>
+          <a:gradFill>
+            <a:gsLst>
+              <a:gs pos="0">
+                <a:schemeClr val="accent1">
+                  <a:alpha val="50000"/>
+                </a:schemeClr>
+              </a:gs>
+              <a:gs pos="100000">
+                <a:schemeClr val="accent1">
+                  <a:lumMod val="50000"/>
+                  <a:alpha val="0"/>
+                </a:schemeClr>
+              </a:gs>
+            </a:gsLst>
+            <a:lin ang="11400000" scaled="0"/>
+          </a:gradFill>
+          <a:ln>
+            <a:noFill/>
+          </a:ln>
+        </p:spPr>
+        <p:style>
+          <a:lnRef idx="2">
+            <a:schemeClr val="accent1">
+              <a:shade val="50000"/>
+            </a:schemeClr>
+          </a:lnRef>
+          <a:fillRef idx="1">
+            <a:schemeClr val="accent1"/>
+          </a:fillRef>
+          <a:effectRef idx="0">
+            <a:schemeClr val="accent1"/>
+          </a:effectRef>
+          <a:fontRef idx="minor">
+            <a:schemeClr val="lt1"/>
+          </a:fontRef>
+        </p:style>
+        <p:txBody>
+          <a:bodyPr rtlCol="0" anchor="ctr"/>
+          <a:lstStyle/>
+          <a:p>
+            <a:pPr algn="ctr"/>
+            <a:endParaRPr lang="en-US"/>
+          </a:p>
+        </p:txBody>
+      </p:sp>
+      <p:sp>
+        <p:nvSpPr>
+          <p:cNvPr id="16" name="Rectangle 15">
+            <a:extLst>
+              <a:ext uri="{FF2B5EF4-FFF2-40B4-BE49-F238E27FC236}">
+                <a16:creationId xmlns:a16="http://schemas.microsoft.com/office/drawing/2014/main" id="{85149191-5F60-4A28-AAFF-039F96B0F3EC}"/>
+              </a:ext>
+              <a:ext uri="{C183D7F6-B498-43B3-948B-1728B52AA6E4}">
+                <adec:decorative xmlns:adec="http://schemas.microsoft.com/office/drawing/2017/decorative" val="1"/>
+              </a:ext>
+            </a:extLst>
+          </p:cNvPr>
+          <p:cNvSpPr>
+            <a:spLocks noGrp="1" noRot="1" noChangeAspect="1" noMove="1" noResize="1" noEditPoints="1" noAdjustHandles="1" noChangeArrowheads="1" noChangeShapeType="1" noTextEdit="1"/>
+          </p:cNvSpPr>
+          <p:nvPr>
+            <p:extLst>
+              <p:ext uri="{386F3935-93C4-4BCD-93E2-E3B085C9AB24}">
+                <p16:designElem xmlns:p16="http://schemas.microsoft.com/office/powerpoint/2015/main" val="1"/>
+              </p:ext>
+            </p:extLst>
+          </p:nvPr>
+        </p:nvSpPr>
+        <p:spPr>
+          <a:xfrm rot="16200000" flipH="1">
+            <a:off x="-1742858" y="2085760"/>
+            <a:ext cx="6857572" cy="2686051"/>
+          </a:xfrm>
+          <a:prstGeom prst="rect">
+            <a:avLst/>
+          </a:prstGeom>
+          <a:gradFill>
+            <a:gsLst>
+              <a:gs pos="0">
+                <a:srgbClr val="000000">
+                  <a:alpha val="59000"/>
+                </a:srgbClr>
+              </a:gs>
+              <a:gs pos="69000">
+                <a:schemeClr val="accent1">
+                  <a:alpha val="0"/>
+                </a:schemeClr>
+              </a:gs>
+            </a:gsLst>
+            <a:lin ang="13200000" scaled="0"/>
+          </a:gradFill>
+          <a:ln>
+            <a:noFill/>
+          </a:ln>
+        </p:spPr>
+        <p:style>
+          <a:lnRef idx="2">
+            <a:schemeClr val="accent1">
+              <a:shade val="50000"/>
+            </a:schemeClr>
+          </a:lnRef>
+          <a:fillRef idx="1">
+            <a:schemeClr val="accent1"/>
+          </a:fillRef>
+          <a:effectRef idx="0">
+            <a:schemeClr val="accent1"/>
+          </a:effectRef>
+          <a:fontRef idx="minor">
+            <a:schemeClr val="lt1"/>
+          </a:fontRef>
+        </p:style>
+        <p:txBody>
+          <a:bodyPr rtlCol="0" anchor="ctr"/>
+          <a:lstStyle/>
+          <a:p>
+            <a:pPr algn="ctr"/>
+            <a:endParaRPr lang="en-US" dirty="0"/>
+          </a:p>
+        </p:txBody>
+      </p:sp>
+      <p:sp>
+        <p:nvSpPr>
+          <p:cNvPr id="18" name="Freeform: Shape 17">
+            <a:extLst>
+              <a:ext uri="{FF2B5EF4-FFF2-40B4-BE49-F238E27FC236}">
+                <a16:creationId xmlns:a16="http://schemas.microsoft.com/office/drawing/2014/main" id="{F8260ED5-17F7-4158-B241-D51DD4CF1B7E}"/>
+              </a:ext>
+              <a:ext uri="{C183D7F6-B498-43B3-948B-1728B52AA6E4}">
+                <adec:decorative xmlns:adec="http://schemas.microsoft.com/office/drawing/2017/decorative" val="1"/>
+              </a:ext>
+            </a:extLst>
+          </p:cNvPr>
+          <p:cNvSpPr>
+            <a:spLocks noGrp="1" noRot="1" noChangeAspect="1" noMove="1" noResize="1" noEditPoints="1" noAdjustHandles="1" noChangeArrowheads="1" noChangeShapeType="1" noTextEdit="1"/>
+          </p:cNvSpPr>
+          <p:nvPr>
+            <p:extLst>
+              <p:ext uri="{386F3935-93C4-4BCD-93E2-E3B085C9AB24}">
+                <p16:designElem xmlns:p16="http://schemas.microsoft.com/office/powerpoint/2015/main" val="1"/>
+              </p:ext>
+            </p:extLst>
+          </p:nvPr>
+        </p:nvSpPr>
+        <p:spPr>
+          <a:xfrm rot="6097846">
+            <a:off x="-1161554" y="1712395"/>
+            <a:ext cx="4808302" cy="3066500"/>
+          </a:xfrm>
+          <a:custGeom>
+            <a:avLst/>
+            <a:gdLst>
+              <a:gd name="connsiteX0" fmla="*/ 48844 w 4808302"/>
+              <a:gd name="connsiteY0" fmla="*/ 2888671 h 4088666"/>
+              <a:gd name="connsiteX1" fmla="*/ 0 w 4808302"/>
+              <a:gd name="connsiteY1" fmla="*/ 2404151 h 4088666"/>
+              <a:gd name="connsiteX2" fmla="*/ 2404151 w 4808302"/>
+              <a:gd name="connsiteY2" fmla="*/ 0 h 4088666"/>
+              <a:gd name="connsiteX3" fmla="*/ 4808302 w 4808302"/>
+              <a:gd name="connsiteY3" fmla="*/ 2404151 h 4088666"/>
+              <a:gd name="connsiteX4" fmla="*/ 4700216 w 4808302"/>
+              <a:gd name="connsiteY4" fmla="*/ 3119072 h 4088666"/>
+              <a:gd name="connsiteX5" fmla="*/ 4643143 w 4808302"/>
+              <a:gd name="connsiteY5" fmla="*/ 3275009 h 4088666"/>
+              <a:gd name="connsiteX6" fmla="*/ 690093 w 4808302"/>
+              <a:gd name="connsiteY6" fmla="*/ 4088666 h 4088666"/>
+              <a:gd name="connsiteX7" fmla="*/ 548991 w 4808302"/>
+              <a:gd name="connsiteY7" fmla="*/ 3933414 h 4088666"/>
+              <a:gd name="connsiteX8" fmla="*/ 48844 w 4808302"/>
+              <a:gd name="connsiteY8" fmla="*/ 2888671 h 4088666"/>
+            </a:gdLst>
+            <a:ahLst/>
+            <a:cxnLst>
+              <a:cxn ang="0">
+                <a:pos x="connsiteX0" y="connsiteY0"/>
+              </a:cxn>
+              <a:cxn ang="0">
+                <a:pos x="connsiteX1" y="connsiteY1"/>
+              </a:cxn>
+              <a:cxn ang="0">
+                <a:pos x="connsiteX2" y="connsiteY2"/>
+              </a:cxn>
+              <a:cxn ang="0">
+                <a:pos x="connsiteX3" y="connsiteY3"/>
+              </a:cxn>
+              <a:cxn ang="0">
+                <a:pos x="connsiteX4" y="connsiteY4"/>
+              </a:cxn>
+              <a:cxn ang="0">
+                <a:pos x="connsiteX5" y="connsiteY5"/>
+              </a:cxn>
+              <a:cxn ang="0">
+                <a:pos x="connsiteX6" y="connsiteY6"/>
+              </a:cxn>
+              <a:cxn ang="0">
+                <a:pos x="connsiteX7" y="connsiteY7"/>
+              </a:cxn>
+              <a:cxn ang="0">
+                <a:pos x="connsiteX8" y="connsiteY8"/>
+              </a:cxn>
+            </a:cxnLst>
+            <a:rect l="l" t="t" r="r" b="b"/>
+            <a:pathLst>
+              <a:path w="4808302" h="4088666">
+                <a:moveTo>
+                  <a:pt x="48844" y="2888671"/>
+                </a:moveTo>
+                <a:cubicBezTo>
+                  <a:pt x="16818" y="2732167"/>
+                  <a:pt x="0" y="2570123"/>
+                  <a:pt x="0" y="2404151"/>
+                </a:cubicBezTo>
+                <a:cubicBezTo>
+                  <a:pt x="0" y="1076375"/>
+                  <a:pt x="1076375" y="0"/>
+                  <a:pt x="2404151" y="0"/>
+                </a:cubicBezTo>
+                <a:cubicBezTo>
+                  <a:pt x="3731927" y="0"/>
+                  <a:pt x="4808302" y="1076375"/>
+                  <a:pt x="4808302" y="2404151"/>
+                </a:cubicBezTo>
+                <a:cubicBezTo>
+                  <a:pt x="4808302" y="2653109"/>
+                  <a:pt x="4770461" y="2893229"/>
+                  <a:pt x="4700216" y="3119072"/>
+                </a:cubicBezTo>
+                <a:lnTo>
+                  <a:pt x="4643143" y="3275009"/>
+                </a:lnTo>
+                <a:lnTo>
+                  <a:pt x="690093" y="4088666"/>
+                </a:lnTo>
+                <a:lnTo>
+                  <a:pt x="548991" y="3933414"/>
+                </a:lnTo>
+                <a:cubicBezTo>
+                  <a:pt x="304015" y="3636572"/>
+                  <a:pt x="128908" y="3279932"/>
+                  <a:pt x="48844" y="2888671"/>
+                </a:cubicBezTo>
+                <a:close/>
+              </a:path>
+            </a:pathLst>
+          </a:custGeom>
+          <a:gradFill>
+            <a:gsLst>
+              <a:gs pos="39000">
+                <a:schemeClr val="accent1">
+                  <a:lumMod val="60000"/>
+                  <a:lumOff val="40000"/>
+                  <a:alpha val="0"/>
+                </a:schemeClr>
+              </a:gs>
+              <a:gs pos="100000">
+                <a:schemeClr val="accent1">
+                  <a:lumMod val="75000"/>
+                  <a:alpha val="26000"/>
+                </a:schemeClr>
+              </a:gs>
+            </a:gsLst>
+            <a:lin ang="18600000" scaled="0"/>
+          </a:gradFill>
+          <a:ln>
+            <a:noFill/>
+          </a:ln>
+        </p:spPr>
+        <p:style>
+          <a:lnRef idx="2">
+            <a:schemeClr val="accent1">
+              <a:shade val="50000"/>
+            </a:schemeClr>
+          </a:lnRef>
+          <a:fillRef idx="1">
+            <a:schemeClr val="accent1"/>
+          </a:fillRef>
+          <a:effectRef idx="0">
+            <a:schemeClr val="accent1"/>
+          </a:effectRef>
+          <a:fontRef idx="minor">
+            <a:schemeClr val="lt1"/>
+          </a:fontRef>
+        </p:style>
+        <p:txBody>
+          <a:bodyPr wrap="square" rtlCol="0" anchor="ctr">
+            <a:noAutofit/>
+          </a:bodyPr>
+          <a:lstStyle/>
+          <a:p>
+            <a:pPr algn="ctr"/>
+            <a:endParaRPr lang="en-US" dirty="0"/>
+          </a:p>
+        </p:txBody>
+      </p:sp>
       <p:sp>
         <p:nvSpPr>
           <p:cNvPr id="2" name="Title 1"/>
@@ -4663,19 +5144,39 @@
             <p:ph type="ctrTitle"/>
           </p:nvPr>
         </p:nvSpPr>
-        <p:spPr/>
-        <p:txBody>
-          <a:bodyPr/>
+        <p:spPr>
+          <a:xfrm>
+            <a:off x="495030" y="2767106"/>
+            <a:ext cx="2160621" cy="3071906"/>
+          </a:xfrm>
+        </p:spPr>
+        <p:txBody>
+          <a:bodyPr anchor="t">
+            <a:normAutofit/>
+          </a:bodyPr>
           <a:lstStyle/>
           <a:p>
-            <a:r>
-              <a:rPr lang="en-US" dirty="0"/>
+            <a:pPr algn="l"/>
+            <a:r>
+              <a:rPr lang="en-US" sz="3500">
+                <a:solidFill>
+                  <a:srgbClr val="FFFFFF"/>
+                </a:solidFill>
+              </a:rPr>
               <a:t>Interpreter in CPS</a:t>
             </a:r>
             <a:br>
-              <a:rPr lang="en-US" dirty="0"/>
+              <a:rPr lang="en-US" sz="3500">
+                <a:solidFill>
+                  <a:srgbClr val="FFFFFF"/>
+                </a:solidFill>
+              </a:rPr>
             </a:br>
-            <a:endParaRPr lang="en-US" dirty="0"/>
+            <a:endParaRPr lang="en-US" sz="3500">
+              <a:solidFill>
+                <a:srgbClr val="FFFFFF"/>
+              </a:solidFill>
+            </a:endParaRPr>
           </a:p>
         </p:txBody>
       </p:sp>
@@ -4689,18 +5190,60 @@
             <p:ph type="subTitle" idx="1"/>
           </p:nvPr>
         </p:nvSpPr>
-        <p:spPr/>
-        <p:txBody>
-          <a:bodyPr/>
+        <p:spPr>
+          <a:xfrm>
+            <a:off x="495031" y="806824"/>
+            <a:ext cx="2189804" cy="1494117"/>
+          </a:xfrm>
+        </p:spPr>
+        <p:txBody>
+          <a:bodyPr anchor="b">
+            <a:normAutofit/>
+          </a:bodyPr>
           <a:lstStyle/>
           <a:p>
-            <a:r>
-              <a:rPr lang="en-US" dirty="0"/>
+            <a:pPr algn="l"/>
+            <a:r>
+              <a:rPr lang="en-US" sz="1700">
+                <a:solidFill>
+                  <a:srgbClr val="FFFFFF"/>
+                </a:solidFill>
+              </a:rPr>
               <a:t>with data-structure continuations</a:t>
             </a:r>
           </a:p>
         </p:txBody>
       </p:sp>
+      <p:pic>
+        <p:nvPicPr>
+          <p:cNvPr id="5" name="Picture 4">
+            <a:extLst>
+              <a:ext uri="{FF2B5EF4-FFF2-40B4-BE49-F238E27FC236}">
+                <a16:creationId xmlns:a16="http://schemas.microsoft.com/office/drawing/2014/main" id="{076B7F9E-D7BF-B86E-0B93-2E52FA96CDEB}"/>
+              </a:ext>
+            </a:extLst>
+          </p:cNvPr>
+          <p:cNvPicPr>
+            <a:picLocks noChangeAspect="1"/>
+          </p:cNvPicPr>
+          <p:nvPr/>
+        </p:nvPicPr>
+        <p:blipFill>
+          <a:blip r:embed="rId3"/>
+          <a:stretch>
+            <a:fillRect/>
+          </a:stretch>
+        </p:blipFill>
+        <p:spPr>
+          <a:xfrm>
+            <a:off x="3376821" y="719344"/>
+            <a:ext cx="5419311" cy="5419311"/>
+          </a:xfrm>
+          <a:prstGeom prst="rect">
+            <a:avLst/>
+          </a:prstGeom>
+        </p:spPr>
+      </p:pic>
     </p:spTree>
     <p:extLst>
       <p:ext uri="{BB962C8B-B14F-4D97-AF65-F5344CB8AC3E}">

</xml_diff>